<commit_message>
fix the second question
</commit_message>
<xml_diff>
--- a/materials/prompt_engineering_3_hour_workshop.pptx
+++ b/materials/prompt_engineering_3_hour_workshop.pptx
@@ -822,7 +822,7 @@
           <a:lstStyle/>
           <a:p>
             <a:r>
-              <a:t>Reserve 6 minutes for feedback, retries, and a short discussion. Use the task-specific maximum points: Lab 1 uses 20/20/20/40; other labs use 25 each. Ask: What makes few-shot examples useful? Correct answer: They demonstrate the intended mapping and consistent format.. Never use model self-confidence as proof of correctness.</a:t>
+              <a:t>Reserve 6 minutes for feedback, retries, and a short discussion. Use the task-specific maximum points: Lab 1 uses 20/20/20/40; other labs use 25 each. Ask: Why is it important to use few-shot examples for edge cases like PII or medical advice? Correct answer: They demonstrate exactly how to format the fallback response without processing the sensitive data.. Never use model self-confidence as proof of correctness.</a:t>
             </a:r>
           </a:p>
         </p:txBody>
@@ -6666,7 +6666,7 @@
               </a:defRPr>
             </a:pPr>
             <a:r>
-              <a:t>Few-shot examples</a:t>
+              <a:t>Few-shot examples: Content Moderation &amp; PII</a:t>
             </a:r>
           </a:p>
         </p:txBody>
@@ -6705,7 +6705,7 @@
               </a:defRPr>
             </a:pPr>
             <a:r>
-              <a:t>Show consistent input/output examples to teach a pattern. Test the pattern on new inputs, including an edge case.</a:t>
+              <a:t>Show consistent input/output examples to teach a pattern, specifically for handling edge cases like PII and safety.</a:t>
             </a:r>
           </a:p>
           <a:p>
@@ -6955,7 +6955,7 @@
               </a:defRPr>
             </a:pPr>
             <a:r>
-              <a:t>Feedback: Password reset email never arrives.</a:t>
+              <a:t>Classify comments as SAFE or TOXIC. Return only the label.</a:t>
             </a:r>
           </a:p>
           <a:p>
@@ -6971,7 +6971,7 @@
               </a:defRPr>
             </a:pPr>
             <a:r>
-              <a:t>Title: [Auth] Password reset email missing</a:t>
+              <a:t>Comment: Great service!</a:t>
             </a:r>
           </a:p>
           <a:p>
@@ -6987,7 +6987,7 @@
               </a:defRPr>
             </a:pPr>
             <a:r>
-              <a:t>Feedback: Dark mode text is unreadable.</a:t>
+              <a:t>Label: SAFE</a:t>
             </a:r>
           </a:p>
           <a:p>
@@ -7003,7 +7003,23 @@
               </a:defRPr>
             </a:pPr>
             <a:r>
-              <a:t>Title: [UI] Low contrast in dark mode</a:t>
+              <a:t>Comment: You people are absolute idiots.</a:t>
+            </a:r>
+          </a:p>
+          <a:p>
+            <a:pPr>
+              <a:spcAft>
+                <a:spcPts val="1600"/>
+              </a:spcAft>
+              <a:defRPr sz="2500" b="0">
+                <a:solidFill>
+                  <a:srgbClr val="F6F8FC"/>
+                </a:solidFill>
+                <a:latin typeface="Aptos"/>
+              </a:defRPr>
+            </a:pPr>
+            <a:r>
+              <a:t>Label: TOXIC</a:t>
             </a:r>
           </a:p>
         </p:txBody>
@@ -7224,7 +7240,36 @@
               </a:defRPr>
             </a:pPr>
             <a:r>
-              <a:t>Write a ticket-title prompt containing 2–4 input/output examples. Require [Area] Description titles of at most 60 characters. Include these test inputs: PDF uploads over 10MB crash on iPhone; Google login fails on Safari; CSV export stops after 100 rows. Request a JSON array of three titles in that order. Submit the prompt, not the final titles.</a:t>
+              <a:t>Your company is an online pharmacy. You need an AI to summarize long user reviews into a single short sentence. However, there are two legal edge cases: 1. Users sometimes include PII like phone numbers or national IDs. 2. Users ask for medical advice (e.g., "Does this interact with aspirin?"). If published, the company faces fines.</a:t>
+            </a:r>
+          </a:p>
+          <a:p>
+            <a:pPr>
+              <a:spcAft>
+                <a:spcPts val="1600"/>
+              </a:spcAft>
+              <a:defRPr sz="2400" b="0">
+                <a:solidFill>
+                  <a:srgbClr val="F6F8FC"/>
+                </a:solidFill>
+                <a:latin typeface="Aptos"/>
+              </a:defRPr>
+            </a:pPr>
+          </a:p>
+          <a:p>
+            <a:pPr>
+              <a:spcAft>
+                <a:spcPts val="1600"/>
+              </a:spcAft>
+              <a:defRPr sz="2400" b="0">
+                <a:solidFill>
+                  <a:srgbClr val="F6F8FC"/>
+                </a:solidFill>
+                <a:latin typeface="Aptos"/>
+              </a:defRPr>
+            </a:pPr>
+            <a:r>
+              <a:t>Write a few-shot prompt that summarizes safe reviews into one sentence, but uses at least two edge-case examples to teach the model to return ONLY the tag [FLAG_PII] if personal info is present, and ONLY the tag [FLAG_MEDICAL] if medical advice is requested, without generating any summary. Do not write the final reviews, just the instructions and examples.</a:t>
             </a:r>
           </a:p>
         </p:txBody>
@@ -7445,7 +7490,7 @@
               </a:defRPr>
             </a:pPr>
             <a:r>
-              <a:t>• Includes 2–4 relevant input/output examples.</a:t>
+              <a:t>• PII Example (20 points): The prompt must include a distinct example demonstrating the PII rule (e.g., phone number or national ID).</a:t>
             </a:r>
           </a:p>
           <a:p>
@@ -7461,7 +7506,7 @@
               </a:defRPr>
             </a:pPr>
             <a:r>
-              <a:t>• Examples consistently demonstrate [Area] Description and the 60-character limit.</a:t>
+              <a:t>• Medical Example (20 points): The prompt must include a distinct example demonstrating the medical advice rule.</a:t>
             </a:r>
           </a:p>
           <a:p>
@@ -7477,7 +7522,7 @@
               </a:defRPr>
             </a:pPr>
             <a:r>
-              <a:t>• Includes all three test inputs with important details, separated from examples.</a:t>
+              <a:t>• Processing Prevention (40 points): In the edge-case examples, the model must be shown returning ONLY the fallback tag ([FLAG_PII] or [FLAG_MEDICAL]) without any accompanying summary or processing of the sensitive text.</a:t>
             </a:r>
           </a:p>
           <a:p>
@@ -7493,7 +7538,7 @@
               </a:defRPr>
             </a:pPr>
             <a:r>
-              <a:t>• Requests a JSON array of three titles in input order while preserving key details.</a:t>
+              <a:t>• Instruction Clarity (20 points): The initial instructions clearly explain the rules for both safe reviews and edge cases, and align perfectly with the behavior demonstrated in the examples.</a:t>
             </a:r>
           </a:p>
         </p:txBody>

</xml_diff>